<commit_message>
Replace Figure 2 with final white-background export
</commit_message>
<xml_diff>
--- a/figures/figure_2_ribosome_selection.pptx
+++ b/figures/figure_2_ribosome_selection.pptx
@@ -399,7 +399,7 @@
           </a:prstGeom>
           <a:extLst>
             <a:ext uri="{C572A759-6A51-4108-AA02-DFA0A04FC94B}">
-              <ma14:wrappingTextBoxFlag xmlns:ma14="http://schemas.microsoft.com/office/mac/drawingml/2011/main" xmlns="" val="0"/>
+              <ma14:wrappingTextBoxFlag xmlns="" xmlns:ma14="http://schemas.microsoft.com/office/mac/drawingml/2011/main" val="0"/>
             </a:ext>
           </a:extLst>
         </p:spPr>
@@ -474,7 +474,7 @@
           </a:prstGeom>
           <a:extLst>
             <a:ext uri="{C572A759-6A51-4108-AA02-DFA0A04FC94B}">
-              <ma14:wrappingTextBoxFlag xmlns:ma14="http://schemas.microsoft.com/office/mac/drawingml/2011/main" xmlns="" val="0"/>
+              <ma14:wrappingTextBoxFlag xmlns="" xmlns:ma14="http://schemas.microsoft.com/office/mac/drawingml/2011/main" val="0"/>
             </a:ext>
           </a:extLst>
         </p:spPr>
@@ -887,7 +887,7 @@
           </a:prstGeom>
           <a:extLst>
             <a:ext uri="{C572A759-6A51-4108-AA02-DFA0A04FC94B}">
-              <ma14:wrappingTextBoxFlag xmlns:ma14="http://schemas.microsoft.com/office/mac/drawingml/2011/main" xmlns="" val="0"/>
+              <ma14:wrappingTextBoxFlag xmlns="" xmlns:ma14="http://schemas.microsoft.com/office/mac/drawingml/2011/main" val="0"/>
             </a:ext>
           </a:extLst>
         </p:spPr>
@@ -2957,38 +2957,6 @@
         </p:sp>
         <p:sp>
           <p:nvSpPr>
-            <p:cNvPr id="133" name="Shape 131"/>
-            <p:cNvSpPr/>
-            <p:nvPr/>
-          </p:nvSpPr>
-          <p:spPr>
-            <a:xfrm>
-              <a:off x="9673882" y="1146471"/>
-              <a:ext cx="118872" cy="118872"/>
-            </a:xfrm>
-            <a:prstGeom prst="ellipse">
-              <a:avLst/>
-            </a:prstGeom>
-            <a:solidFill>
-              <a:srgbClr val="5A8AC6"/>
-            </a:solidFill>
-            <a:ln w="6350">
-              <a:solidFill>
-                <a:srgbClr val="6B6B6B"/>
-              </a:solidFill>
-              <a:prstDash val="solid"/>
-            </a:ln>
-          </p:spPr>
-          <p:txBody>
-            <a:bodyPr/>
-            <a:lstStyle/>
-            <a:p>
-              <a:endParaRPr lang="en-US"/>
-            </a:p>
-          </p:txBody>
-        </p:sp>
-        <p:sp>
-          <p:nvSpPr>
             <p:cNvPr id="134" name="Shape 132"/>
             <p:cNvSpPr/>
             <p:nvPr/>
@@ -3025,7 +2993,7 @@
           </p:nvSpPr>
           <p:spPr>
             <a:xfrm>
-              <a:off x="9774466" y="1073319"/>
+              <a:off x="9653739" y="1140333"/>
               <a:ext cx="118872" cy="118872"/>
             </a:xfrm>
             <a:prstGeom prst="ellipse">
@@ -3087,7 +3055,7 @@
           </p:nvSpPr>
           <p:spPr>
             <a:xfrm>
-              <a:off x="9875050" y="1000167"/>
+              <a:off x="9754323" y="1067181"/>
               <a:ext cx="118872" cy="118872"/>
             </a:xfrm>
             <a:prstGeom prst="ellipse">
@@ -3149,7 +3117,7 @@
           </p:nvSpPr>
           <p:spPr>
             <a:xfrm>
-              <a:off x="9975634" y="927015"/>
+              <a:off x="9854906" y="994029"/>
               <a:ext cx="118872" cy="118872"/>
             </a:xfrm>
             <a:prstGeom prst="ellipse">
@@ -4580,7 +4548,7 @@
               <a:avLst/>
             </a:prstGeom>
             <a:solidFill>
-              <a:srgbClr val="7B61A8"/>
+              <a:srgbClr val="0070C0"/>
             </a:solidFill>
             <a:ln w="6350">
               <a:solidFill>
@@ -4618,7 +4586,7 @@
               <a:avLst/>
             </a:prstGeom>
             <a:solidFill>
-              <a:srgbClr val="7B61A8"/>
+              <a:srgbClr val="0070C0"/>
             </a:solidFill>
             <a:ln w="6350">
               <a:solidFill>
@@ -4656,7 +4624,7 @@
               <a:avLst/>
             </a:prstGeom>
             <a:solidFill>
-              <a:srgbClr val="E46F61"/>
+              <a:schemeClr val="accent2"/>
             </a:solidFill>
             <a:ln w="6350">
               <a:solidFill>
@@ -4694,7 +4662,7 @@
               <a:avLst/>
             </a:prstGeom>
             <a:solidFill>
-              <a:srgbClr val="E46F61"/>
+              <a:schemeClr val="accent2"/>
             </a:solidFill>
             <a:ln w="6350">
               <a:solidFill>
@@ -4732,7 +4700,7 @@
               <a:avLst/>
             </a:prstGeom>
             <a:solidFill>
-              <a:srgbClr val="E46F61"/>
+              <a:schemeClr val="accent2"/>
             </a:solidFill>
             <a:ln w="6350">
               <a:solidFill>
@@ -4770,7 +4738,7 @@
               <a:avLst/>
             </a:prstGeom>
             <a:solidFill>
-              <a:srgbClr val="E46F61"/>
+              <a:schemeClr val="accent2"/>
             </a:solidFill>
             <a:ln w="6350">
               <a:solidFill>
@@ -4808,7 +4776,7 @@
               <a:avLst/>
             </a:prstGeom>
             <a:solidFill>
-              <a:srgbClr val="E46F61"/>
+              <a:schemeClr val="accent2"/>
             </a:solidFill>
             <a:ln w="6350">
               <a:solidFill>
@@ -4846,7 +4814,7 @@
               <a:avLst/>
             </a:prstGeom>
             <a:solidFill>
-              <a:srgbClr val="7B61A8"/>
+              <a:srgbClr val="0070C0"/>
             </a:solidFill>
             <a:ln w="6350">
               <a:solidFill>
@@ -4884,7 +4852,7 @@
               <a:avLst/>
             </a:prstGeom>
             <a:solidFill>
-              <a:srgbClr val="7B61A8"/>
+              <a:srgbClr val="0070C0"/>
             </a:solidFill>
             <a:ln w="6350">
               <a:solidFill>
@@ -5588,38 +5556,6 @@
         </p:sp>
         <p:sp>
           <p:nvSpPr>
-            <p:cNvPr id="132" name="Shape 130"/>
-            <p:cNvSpPr/>
-            <p:nvPr/>
-          </p:nvSpPr>
-          <p:spPr>
-            <a:xfrm>
-              <a:off x="9569504" y="1223417"/>
-              <a:ext cx="118872" cy="118872"/>
-            </a:xfrm>
-            <a:prstGeom prst="ellipse">
-              <a:avLst/>
-            </a:prstGeom>
-            <a:solidFill>
-              <a:srgbClr val="7B61A8"/>
-            </a:solidFill>
-            <a:ln w="6350">
-              <a:solidFill>
-                <a:srgbClr val="6B6B6B"/>
-              </a:solidFill>
-              <a:prstDash val="solid"/>
-            </a:ln>
-          </p:spPr>
-          <p:txBody>
-            <a:bodyPr/>
-            <a:lstStyle/>
-            <a:p>
-              <a:endParaRPr lang="en-US"/>
-            </a:p>
-          </p:txBody>
-        </p:sp>
-        <p:sp>
-          <p:nvSpPr>
             <p:cNvPr id="299" name="Shape 135">
               <a:extLst>
                 <a:ext uri="{FF2B5EF4-FFF2-40B4-BE49-F238E27FC236}">
@@ -5639,7 +5575,7 @@
               <a:avLst/>
             </a:prstGeom>
             <a:solidFill>
-              <a:srgbClr val="E46F61"/>
+              <a:schemeClr val="accent2"/>
             </a:solidFill>
             <a:ln w="6350">
               <a:solidFill>
@@ -5716,7 +5652,7 @@
               <a:avLst/>
             </a:prstGeom>
             <a:solidFill>
-              <a:srgbClr val="7B61A8"/>
+              <a:srgbClr val="0070C0"/>
             </a:solidFill>
             <a:ln w="6350">
               <a:solidFill>
@@ -5793,7 +5729,39 @@
               <a:avLst/>
             </a:prstGeom>
             <a:solidFill>
-              <a:srgbClr val="7B61A8"/>
+              <a:srgbClr val="0070C0"/>
+            </a:solidFill>
+            <a:ln w="6350">
+              <a:solidFill>
+                <a:srgbClr val="6B6B6B"/>
+              </a:solidFill>
+              <a:prstDash val="solid"/>
+            </a:ln>
+          </p:spPr>
+          <p:txBody>
+            <a:bodyPr/>
+            <a:lstStyle/>
+            <a:p>
+              <a:endParaRPr lang="en-US"/>
+            </a:p>
+          </p:txBody>
+        </p:sp>
+        <p:sp>
+          <p:nvSpPr>
+            <p:cNvPr id="133" name="Shape 131"/>
+            <p:cNvSpPr/>
+            <p:nvPr/>
+          </p:nvSpPr>
+          <p:spPr>
+            <a:xfrm>
+              <a:off x="9553156" y="1213485"/>
+              <a:ext cx="118872" cy="118872"/>
+            </a:xfrm>
+            <a:prstGeom prst="ellipse">
+              <a:avLst/>
+            </a:prstGeom>
+            <a:solidFill>
+              <a:srgbClr val="0070C0"/>
             </a:solidFill>
             <a:ln w="6350">
               <a:solidFill>

</xml_diff>